<commit_message>
Add open source link to defense deck
</commit_message>
<xml_diff>
--- a/plans/plan_final_pre/final_defense_deck/final_defense_l2_book_v2.pptx
+++ b/plans/plan_final_pre/final_defense_deck/final_defense_l2_book_v2.pptx
@@ -7080,6 +7080,322 @@
           </a:p>
         </p:txBody>
       </p:sp>
+      <p:sp>
+        <p:nvSpPr>
+          <p:cNvPr id="33" name="Shape 31"/>
+          <p:cNvSpPr/>
+          <p:nvPr/>
+        </p:nvSpPr>
+        <p:spPr>
+          <a:xfrm>
+            <a:off x="987552" y="5596128"/>
+            <a:ext cx="10222992" cy="530352"/>
+          </a:xfrm>
+          <a:prstGeom prst="rect">
+            <a:avLst/>
+          </a:prstGeom>
+          <a:solidFill>
+            <a:srgbClr val="15364B"/>
+          </a:solidFill>
+          <a:ln w="8890">
+            <a:solidFill>
+              <a:srgbClr val="15364B"/>
+            </a:solidFill>
+            <a:prstDash val="solid"/>
+          </a:ln>
+        </p:spPr>
+      </p:sp>
+      <p:sp>
+        <p:nvSpPr>
+          <p:cNvPr id="34" name="Shape 32"/>
+          <p:cNvSpPr/>
+          <p:nvPr/>
+        </p:nvSpPr>
+        <p:spPr>
+          <a:xfrm>
+            <a:off x="987552" y="5596128"/>
+            <a:ext cx="73152" cy="530352"/>
+          </a:xfrm>
+          <a:prstGeom prst="rect">
+            <a:avLst/>
+          </a:prstGeom>
+          <a:solidFill>
+            <a:srgbClr val="279C95"/>
+          </a:solidFill>
+          <a:ln w="12700">
+            <a:solidFill>
+              <a:srgbClr val="279C95">
+                <a:alpha val="0"/>
+              </a:srgbClr>
+            </a:solidFill>
+            <a:prstDash val="solid"/>
+          </a:ln>
+        </p:spPr>
+      </p:sp>
+      <p:sp>
+        <p:nvSpPr>
+          <p:cNvPr id="35" name="Text 33"/>
+          <p:cNvSpPr/>
+          <p:nvPr/>
+        </p:nvSpPr>
+        <p:spPr>
+          <a:xfrm>
+            <a:off x="1261872" y="5742432"/>
+            <a:ext cx="1389888" cy="164592"/>
+          </a:xfrm>
+          <a:prstGeom prst="rect">
+            <a:avLst/>
+          </a:prstGeom>
+          <a:noFill/>
+          <a:ln/>
+        </p:spPr>
+        <p:txBody>
+          <a:bodyPr wrap="square" lIns="0" tIns="0" rIns="0" bIns="0" rtlCol="0" anchor="t">
+            <a:normAutofit/>
+          </a:bodyPr>
+          <a:lstStyle/>
+          <a:p>
+            <a:pPr algn="l" indent="0" marL="0">
+              <a:buNone/>
+            </a:pPr>
+            <a:r>
+              <a:rPr lang="en-US" sz="860" b="1" dirty="0">
+                <a:solidFill>
+                  <a:srgbClr val="FFFFFF"/>
+                </a:solidFill>
+                <a:latin typeface="Noto Sans CJK SC" pitchFamily="34" charset="0"/>
+                <a:ea typeface="Noto Sans CJK SC" pitchFamily="34" charset="-122"/>
+                <a:cs typeface="Noto Sans CJK SC" pitchFamily="34" charset="-120"/>
+              </a:rPr>
+              <a:t>开源与复现实验</a:t>
+            </a:r>
+            <a:endParaRPr lang="en-US" sz="860" dirty="0"/>
+          </a:p>
+        </p:txBody>
+      </p:sp>
+      <p:sp>
+        <p:nvSpPr>
+          <p:cNvPr id="36" name="Text 34"/>
+          <p:cNvSpPr/>
+          <p:nvPr/>
+        </p:nvSpPr>
+        <p:spPr>
+          <a:xfrm>
+            <a:off x="3072384" y="5687568"/>
+            <a:ext cx="438912" cy="128016"/>
+          </a:xfrm>
+          <a:prstGeom prst="rect">
+            <a:avLst/>
+          </a:prstGeom>
+          <a:noFill/>
+          <a:ln/>
+        </p:spPr>
+        <p:txBody>
+          <a:bodyPr wrap="square" lIns="0" tIns="0" rIns="0" bIns="0" rtlCol="0" anchor="t">
+            <a:normAutofit/>
+          </a:bodyPr>
+          <a:lstStyle/>
+          <a:p>
+            <a:pPr algn="l" indent="0" marL="0">
+              <a:buNone/>
+            </a:pPr>
+            <a:r>
+              <a:rPr lang="en-US" sz="660" b="1" dirty="0">
+                <a:solidFill>
+                  <a:srgbClr val="279C95"/>
+                </a:solidFill>
+                <a:latin typeface="Noto Sans CJK SC" pitchFamily="34" charset="0"/>
+                <a:ea typeface="Noto Sans CJK SC" pitchFamily="34" charset="-122"/>
+                <a:cs typeface="Noto Sans CJK SC" pitchFamily="34" charset="-120"/>
+              </a:rPr>
+              <a:t>Code</a:t>
+            </a:r>
+            <a:endParaRPr lang="en-US" sz="660" dirty="0"/>
+          </a:p>
+        </p:txBody>
+      </p:sp>
+      <p:sp>
+        <p:nvSpPr>
+          <p:cNvPr id="37" name="Text 35">
+            <a:hlinkClick r:id="rId1" tooltip=""/>
+          </p:cNvPr>
+          <p:cNvSpPr/>
+          <p:nvPr/>
+        </p:nvSpPr>
+        <p:spPr>
+          <a:xfrm>
+            <a:off x="3072384" y="5843016"/>
+            <a:ext cx="3749040" cy="146304"/>
+          </a:xfrm>
+          <a:prstGeom prst="rect">
+            <a:avLst/>
+          </a:prstGeom>
+          <a:noFill/>
+          <a:ln/>
+        </p:spPr>
+        <p:txBody>
+          <a:bodyPr wrap="square" lIns="0" tIns="0" rIns="0" bIns="0" rtlCol="0" anchor="t">
+            <a:normAutofit/>
+          </a:bodyPr>
+          <a:lstStyle/>
+          <a:p>
+            <a:pPr algn="l" indent="0" marL="0">
+              <a:buNone/>
+            </a:pPr>
+            <a:r>
+              <a:rPr lang="en-US" sz="680" u="sng" dirty="0">
+                <a:solidFill>
+                  <a:srgbClr val="FFFFFF"/>
+                </a:solidFill>
+                <a:latin typeface="Noto Sans CJK SC" pitchFamily="34" charset="0"/>
+                <a:ea typeface="Noto Sans CJK SC" pitchFamily="34" charset="-122"/>
+                <a:cs typeface="Noto Sans CJK SC" pitchFamily="34" charset="-120"/>
+                <a:hlinkClick r:id="rId1" invalidUrl="" action="" tgtFrame="" tooltip="" history="1" highlightClick="0" endSnd="0">
+                  <a:extLst>
+                    <a:ext uri="{A12FA001-AC4F-418D-AE19-62706E023703}">
+                      <ahyp:hlinkClr xmlns:ahyp="http://schemas.microsoft.com/office/drawing/2018/hyperlinkcolor" val="tx"/>
+                    </a:ext>
+                  </a:extLst>
+                </a:hlinkClick>
+              </a:rPr>
+              <a:t>github.com/Arandott/nautilus_trader/tree/cbw/l2-book-upload</a:t>
+            </a:r>
+            <a:endParaRPr lang="en-US" sz="680" dirty="0"/>
+          </a:p>
+        </p:txBody>
+      </p:sp>
+      <p:sp>
+        <p:nvSpPr>
+          <p:cNvPr id="38" name="Text 36"/>
+          <p:cNvSpPr/>
+          <p:nvPr/>
+        </p:nvSpPr>
+        <p:spPr>
+          <a:xfrm>
+            <a:off x="7315200" y="5687568"/>
+            <a:ext cx="713232" cy="128016"/>
+          </a:xfrm>
+          <a:prstGeom prst="rect">
+            <a:avLst/>
+          </a:prstGeom>
+          <a:noFill/>
+          <a:ln/>
+        </p:spPr>
+        <p:txBody>
+          <a:bodyPr wrap="square" lIns="0" tIns="0" rIns="0" bIns="0" rtlCol="0" anchor="t">
+            <a:normAutofit/>
+          </a:bodyPr>
+          <a:lstStyle/>
+          <a:p>
+            <a:pPr algn="l" indent="0" marL="0">
+              <a:buNone/>
+            </a:pPr>
+            <a:r>
+              <a:rPr lang="en-US" sz="660" b="1" dirty="0">
+                <a:solidFill>
+                  <a:srgbClr val="279C95"/>
+                </a:solidFill>
+                <a:latin typeface="Noto Sans CJK SC" pitchFamily="34" charset="0"/>
+                <a:ea typeface="Noto Sans CJK SC" pitchFamily="34" charset="-122"/>
+                <a:cs typeface="Noto Sans CJK SC" pitchFamily="34" charset="-120"/>
+              </a:rPr>
+              <a:t>README</a:t>
+            </a:r>
+            <a:endParaRPr lang="en-US" sz="660" dirty="0"/>
+          </a:p>
+        </p:txBody>
+      </p:sp>
+      <p:sp>
+        <p:nvSpPr>
+          <p:cNvPr id="39" name="Text 37">
+            <a:hlinkClick r:id="rId2" tooltip=""/>
+          </p:cNvPr>
+          <p:cNvSpPr/>
+          <p:nvPr/>
+        </p:nvSpPr>
+        <p:spPr>
+          <a:xfrm>
+            <a:off x="7315200" y="5843016"/>
+            <a:ext cx="1828800" cy="146304"/>
+          </a:xfrm>
+          <a:prstGeom prst="rect">
+            <a:avLst/>
+          </a:prstGeom>
+          <a:noFill/>
+          <a:ln/>
+        </p:spPr>
+        <p:txBody>
+          <a:bodyPr wrap="square" lIns="0" tIns="0" rIns="0" bIns="0" rtlCol="0" anchor="t">
+            <a:normAutofit/>
+          </a:bodyPr>
+          <a:lstStyle/>
+          <a:p>
+            <a:pPr algn="l" indent="0" marL="0">
+              <a:buNone/>
+            </a:pPr>
+            <a:r>
+              <a:rPr lang="en-US" sz="680" u="sng" dirty="0">
+                <a:solidFill>
+                  <a:srgbClr val="FFFFFF"/>
+                </a:solidFill>
+                <a:latin typeface="Noto Sans CJK SC" pitchFamily="34" charset="0"/>
+                <a:ea typeface="Noto Sans CJK SC" pitchFamily="34" charset="-122"/>
+                <a:cs typeface="Noto Sans CJK SC" pitchFamily="34" charset="-120"/>
+                <a:hlinkClick r:id="rId2" invalidUrl="" action="" tgtFrame="" tooltip="" history="1" highlightClick="0" endSnd="0">
+                  <a:extLst>
+                    <a:ext uri="{A12FA001-AC4F-418D-AE19-62706E023703}">
+                      <ahyp:hlinkClr xmlns:ahyp="http://schemas.microsoft.com/office/drawing/2018/hyperlinkcolor" val="tx"/>
+                    </a:ext>
+                  </a:extLst>
+                </a:hlinkClick>
+              </a:rPr>
+              <a:t>README_L2_BOOK.md</a:t>
+            </a:r>
+            <a:endParaRPr lang="en-US" sz="680" dirty="0"/>
+          </a:p>
+        </p:txBody>
+      </p:sp>
+      <p:sp>
+        <p:nvSpPr>
+          <p:cNvPr id="40" name="Text 38"/>
+          <p:cNvSpPr/>
+          <p:nvPr/>
+        </p:nvSpPr>
+        <p:spPr>
+          <a:xfrm>
+            <a:off x="9326880" y="5797296"/>
+            <a:ext cx="1609344" cy="164592"/>
+          </a:xfrm>
+          <a:prstGeom prst="rect">
+            <a:avLst/>
+          </a:prstGeom>
+          <a:noFill/>
+          <a:ln/>
+        </p:spPr>
+        <p:txBody>
+          <a:bodyPr wrap="square" lIns="0" tIns="0" rIns="0" bIns="0" rtlCol="0" anchor="t">
+            <a:normAutofit/>
+          </a:bodyPr>
+          <a:lstStyle/>
+          <a:p>
+            <a:pPr algn="l" indent="0" marL="0">
+              <a:buNone/>
+            </a:pPr>
+            <a:r>
+              <a:rPr lang="en-US" sz="640" dirty="0">
+                <a:solidFill>
+                  <a:srgbClr val="C8D7E2"/>
+                </a:solidFill>
+                <a:latin typeface="Noto Sans CJK SC" pitchFamily="34" charset="0"/>
+                <a:ea typeface="Noto Sans CJK SC" pitchFamily="34" charset="-122"/>
+                <a:cs typeface="Noto Sans CJK SC" pitchFamily="34" charset="-120"/>
+              </a:rPr>
+              <a:t>包含 benchmark、真实 replay、Rust/Python e2e 运行入口</a:t>
+            </a:r>
+            <a:endParaRPr lang="en-US" sz="640" dirty="0"/>
+          </a:p>
+        </p:txBody>
+      </p:sp>
     </p:spTree>
   </p:cSld>
   <p:clrMapOvr>

</xml_diff>